<commit_message>
Quartz sync: Oct 13, 2025, 10:42 PM
</commit_message>
<xml_diff>
--- a/content/Articles/session38tokens.pptx
+++ b/content/Articles/session38tokens.pptx
@@ -6,6 +6,7 @@
   </p:sldMasterIdLst>
   <p:sldIdLst>
     <p:sldId id="274" r:id="rId2"/>
+    <p:sldId id="275" r:id="rId3"/>
   </p:sldIdLst>
   <p:sldSz cx="7772400" cy="10058400"/>
   <p:notesSz cx="7315200" cy="9601200"/>
@@ -115,7 +116,7 @@
 <file path=ppt/revisionInfo.xml><?xml version="1.0" encoding="utf-8"?>
 <p1510:revInfo xmlns:a="http://schemas.openxmlformats.org/drawingml/2006/main" xmlns:r="http://schemas.openxmlformats.org/officeDocument/2006/relationships" xmlns:p1510="http://schemas.microsoft.com/office/powerpoint/2015/10/main">
   <p1510:revLst>
-    <p1510:client id="{C7780FBE-675A-4695-950B-AC815F932029}" v="248" dt="2025-10-09T03:13:56.769"/>
+    <p1510:client id="{C7780FBE-675A-4695-950B-AC815F932029}" v="252" dt="2025-10-13T05:11:25.515"/>
   </p1510:revLst>
 </p1510:revInfo>
 </file>
@@ -125,7 +126,7 @@
   <pc:docChgLst>
     <pc:chgData name="Jack Bond" userId="d0613b4d9d68792d" providerId="LiveId" clId="{DAEA3D54-AD02-4E1B-A73A-AB467D915B21}"/>
     <pc:docChg chg="undo custSel addSld delSld modSld">
-      <pc:chgData name="Jack Bond" userId="d0613b4d9d68792d" providerId="LiveId" clId="{DAEA3D54-AD02-4E1B-A73A-AB467D915B21}" dt="2025-10-09T03:14:06.543" v="427" actId="1076"/>
+      <pc:chgData name="Jack Bond" userId="d0613b4d9d68792d" providerId="LiveId" clId="{DAEA3D54-AD02-4E1B-A73A-AB467D915B21}" dt="2025-10-13T05:11:25.513" v="434" actId="1367"/>
       <pc:docMkLst>
         <pc:docMk/>
       </pc:docMkLst>
@@ -157,44 +158,12 @@
             <ac:grpSpMk id="2" creationId="{05EEA92C-1C51-A63C-AFE0-88E4AE1E3021}"/>
           </ac:grpSpMkLst>
         </pc:grpChg>
-        <pc:grpChg chg="add del mod">
-          <ac:chgData name="Jack Bond" userId="d0613b4d9d68792d" providerId="LiveId" clId="{DAEA3D54-AD02-4E1B-A73A-AB467D915B21}" dt="2025-10-09T02:34:29.723" v="193" actId="478"/>
-          <ac:grpSpMkLst>
-            <pc:docMk/>
-            <pc:sldMk cId="3346064594" sldId="274"/>
-            <ac:grpSpMk id="8" creationId="{484337AA-F6A9-5CDE-63C3-BC2CF218F8EB}"/>
-          </ac:grpSpMkLst>
-        </pc:grpChg>
         <pc:grpChg chg="add mod">
           <ac:chgData name="Jack Bond" userId="d0613b4d9d68792d" providerId="LiveId" clId="{DAEA3D54-AD02-4E1B-A73A-AB467D915B21}" dt="2025-10-09T03:14:06.543" v="427" actId="1076"/>
           <ac:grpSpMkLst>
             <pc:docMk/>
             <pc:sldMk cId="3346064594" sldId="274"/>
             <ac:grpSpMk id="17" creationId="{274A55F7-800E-B6D9-51FF-C53A7273ABD6}"/>
-          </ac:grpSpMkLst>
-        </pc:grpChg>
-        <pc:grpChg chg="add mod">
-          <ac:chgData name="Jack Bond" userId="d0613b4d9d68792d" providerId="LiveId" clId="{DAEA3D54-AD02-4E1B-A73A-AB467D915B21}" dt="2025-10-09T03:12:02.564" v="386" actId="164"/>
-          <ac:grpSpMkLst>
-            <pc:docMk/>
-            <pc:sldMk cId="3346064594" sldId="274"/>
-            <ac:grpSpMk id="21" creationId="{8E39E362-9C55-BD12-0935-4ACAF43C29D8}"/>
-          </ac:grpSpMkLst>
-        </pc:grpChg>
-        <pc:grpChg chg="add del mod">
-          <ac:chgData name="Jack Bond" userId="d0613b4d9d68792d" providerId="LiveId" clId="{DAEA3D54-AD02-4E1B-A73A-AB467D915B21}" dt="2025-10-09T03:13:49.222" v="423" actId="478"/>
-          <ac:grpSpMkLst>
-            <pc:docMk/>
-            <pc:sldMk cId="3346064594" sldId="274"/>
-            <ac:grpSpMk id="22" creationId="{5EE5B432-72FF-6001-88FA-5AB5BACD543B}"/>
-          </ac:grpSpMkLst>
-        </pc:grpChg>
-        <pc:grpChg chg="add del mod">
-          <ac:chgData name="Jack Bond" userId="d0613b4d9d68792d" providerId="LiveId" clId="{DAEA3D54-AD02-4E1B-A73A-AB467D915B21}" dt="2025-10-09T03:12:50.553" v="404" actId="21"/>
-          <ac:grpSpMkLst>
-            <pc:docMk/>
-            <pc:sldMk cId="3346064594" sldId="274"/>
-            <ac:grpSpMk id="23" creationId="{4B261396-8A0C-57AB-F24C-420CA2EF05FC}"/>
           </ac:grpSpMkLst>
         </pc:grpChg>
         <pc:grpChg chg="add mod">
@@ -230,54 +199,6 @@
           </ac:picMkLst>
         </pc:picChg>
         <pc:picChg chg="add mod">
-          <ac:chgData name="Jack Bond" userId="d0613b4d9d68792d" providerId="LiveId" clId="{DAEA3D54-AD02-4E1B-A73A-AB467D915B21}" dt="2025-10-09T01:21:51.860" v="9" actId="688"/>
-          <ac:picMkLst>
-            <pc:docMk/>
-            <pc:sldMk cId="3346064594" sldId="274"/>
-            <ac:picMk id="6" creationId="{295D3EEC-73EB-7E6B-5462-BE3A982C6606}"/>
-          </ac:picMkLst>
-        </pc:picChg>
-        <pc:picChg chg="add mod">
-          <ac:chgData name="Jack Bond" userId="d0613b4d9d68792d" providerId="LiveId" clId="{DAEA3D54-AD02-4E1B-A73A-AB467D915B21}" dt="2025-10-09T01:21:51.860" v="9" actId="688"/>
-          <ac:picMkLst>
-            <pc:docMk/>
-            <pc:sldMk cId="3346064594" sldId="274"/>
-            <ac:picMk id="7" creationId="{DB0A1157-F83D-FAF9-B1D7-A218A44F0E22}"/>
-          </ac:picMkLst>
-        </pc:picChg>
-        <pc:picChg chg="add del mod ord modCrop">
-          <ac:chgData name="Jack Bond" userId="d0613b4d9d68792d" providerId="LiveId" clId="{DAEA3D54-AD02-4E1B-A73A-AB467D915B21}" dt="2025-10-09T02:34:09.190" v="187" actId="478"/>
-          <ac:picMkLst>
-            <pc:docMk/>
-            <pc:sldMk cId="3346064594" sldId="274"/>
-            <ac:picMk id="10" creationId="{425E6BC8-32A0-AE94-3886-EA059D569411}"/>
-          </ac:picMkLst>
-        </pc:picChg>
-        <pc:picChg chg="add del mod ord">
-          <ac:chgData name="Jack Bond" userId="d0613b4d9d68792d" providerId="LiveId" clId="{DAEA3D54-AD02-4E1B-A73A-AB467D915B21}" dt="2025-10-09T02:34:12.795" v="188" actId="478"/>
-          <ac:picMkLst>
-            <pc:docMk/>
-            <pc:sldMk cId="3346064594" sldId="274"/>
-            <ac:picMk id="12" creationId="{57780BA4-BAE1-9188-C474-AD72BC29575C}"/>
-          </ac:picMkLst>
-        </pc:picChg>
-        <pc:picChg chg="add del mod modCrop">
-          <ac:chgData name="Jack Bond" userId="d0613b4d9d68792d" providerId="LiveId" clId="{DAEA3D54-AD02-4E1B-A73A-AB467D915B21}" dt="2025-10-09T02:34:12.795" v="188" actId="478"/>
-          <ac:picMkLst>
-            <pc:docMk/>
-            <pc:sldMk cId="3346064594" sldId="274"/>
-            <ac:picMk id="13" creationId="{C51A1694-3A5E-27D0-E9D0-D4D3CDCAC2F4}"/>
-          </ac:picMkLst>
-        </pc:picChg>
-        <pc:picChg chg="add del mod modCrop">
-          <ac:chgData name="Jack Bond" userId="d0613b4d9d68792d" providerId="LiveId" clId="{DAEA3D54-AD02-4E1B-A73A-AB467D915B21}" dt="2025-10-09T02:34:12.795" v="188" actId="478"/>
-          <ac:picMkLst>
-            <pc:docMk/>
-            <pc:sldMk cId="3346064594" sldId="274"/>
-            <ac:picMk id="14" creationId="{DE51AEA9-1F54-D243-5D72-430D4457202A}"/>
-          </ac:picMkLst>
-        </pc:picChg>
-        <pc:picChg chg="add mod">
           <ac:chgData name="Jack Bond" userId="d0613b4d9d68792d" providerId="LiveId" clId="{DAEA3D54-AD02-4E1B-A73A-AB467D915B21}" dt="2025-10-09T02:35:01.813" v="204" actId="164"/>
           <ac:picMkLst>
             <pc:docMk/>
@@ -301,46 +222,6 @@
             <ac:picMk id="19" creationId="{1A00948C-F427-647D-B373-49B3BD958E81}"/>
           </ac:picMkLst>
         </pc:picChg>
-        <pc:picChg chg="add del mod">
-          <ac:chgData name="Jack Bond" userId="d0613b4d9d68792d" providerId="LiveId" clId="{DAEA3D54-AD02-4E1B-A73A-AB467D915B21}" dt="2025-10-09T03:05:44.716" v="336" actId="478"/>
-          <ac:picMkLst>
-            <pc:docMk/>
-            <pc:sldMk cId="3346064594" sldId="274"/>
-            <ac:picMk id="20" creationId="{13658C60-2923-AD4D-BD88-0910CA4735B6}"/>
-          </ac:picMkLst>
-        </pc:picChg>
-        <pc:picChg chg="mod">
-          <ac:chgData name="Jack Bond" userId="d0613b4d9d68792d" providerId="LiveId" clId="{DAEA3D54-AD02-4E1B-A73A-AB467D915B21}" dt="2025-10-09T03:12:49.481" v="403" actId="1076"/>
-          <ac:picMkLst>
-            <pc:docMk/>
-            <pc:sldMk cId="3346064594" sldId="274"/>
-            <ac:picMk id="24" creationId="{C56A0EBD-154C-C04E-5B2C-838F9EC9242D}"/>
-          </ac:picMkLst>
-        </pc:picChg>
-        <pc:picChg chg="mod">
-          <ac:chgData name="Jack Bond" userId="d0613b4d9d68792d" providerId="LiveId" clId="{DAEA3D54-AD02-4E1B-A73A-AB467D915B21}" dt="2025-10-09T03:12:49.481" v="403" actId="1076"/>
-          <ac:picMkLst>
-            <pc:docMk/>
-            <pc:sldMk cId="3346064594" sldId="274"/>
-            <ac:picMk id="25" creationId="{3FE756BE-17DC-B2FA-9AAC-AB0A580C3A50}"/>
-          </ac:picMkLst>
-        </pc:picChg>
-        <pc:picChg chg="add del mod">
-          <ac:chgData name="Jack Bond" userId="d0613b4d9d68792d" providerId="LiveId" clId="{DAEA3D54-AD02-4E1B-A73A-AB467D915B21}" dt="2025-10-09T03:13:05.904" v="412" actId="478"/>
-          <ac:picMkLst>
-            <pc:docMk/>
-            <pc:sldMk cId="3346064594" sldId="274"/>
-            <ac:picMk id="26" creationId="{222BB235-77A6-EF19-BC2D-3DA863A25F99}"/>
-          </ac:picMkLst>
-        </pc:picChg>
-        <pc:picChg chg="add del mod">
-          <ac:chgData name="Jack Bond" userId="d0613b4d9d68792d" providerId="LiveId" clId="{DAEA3D54-AD02-4E1B-A73A-AB467D915B21}" dt="2025-10-09T03:13:05.904" v="412" actId="478"/>
-          <ac:picMkLst>
-            <pc:docMk/>
-            <pc:sldMk cId="3346064594" sldId="274"/>
-            <ac:picMk id="27" creationId="{E5292559-33D4-BCF3-AC74-D6313EB259A6}"/>
-          </ac:picMkLst>
-        </pc:picChg>
         <pc:picChg chg="add mod">
           <ac:chgData name="Jack Bond" userId="d0613b4d9d68792d" providerId="LiveId" clId="{DAEA3D54-AD02-4E1B-A73A-AB467D915B21}" dt="2025-10-09T03:13:56.769" v="425" actId="164"/>
           <ac:picMkLst>
@@ -357,20 +238,27 @@
             <ac:picMk id="29" creationId="{B04AA422-9FDF-A456-37FA-A579BEF350A6}"/>
           </ac:picMkLst>
         </pc:picChg>
-        <pc:picChg chg="add">
-          <ac:chgData name="Jack Bond" userId="d0613b4d9d68792d" providerId="LiveId" clId="{DAEA3D54-AD02-4E1B-A73A-AB467D915B21}" dt="2025-10-09T02:21:24.013" v="32"/>
-          <ac:picMkLst>
-            <pc:docMk/>
-            <pc:sldMk cId="3346064594" sldId="274"/>
-            <ac:picMk id="1026" creationId="{9C4DF453-EFB9-4515-9CA8-F94AD7D0062A}"/>
-          </ac:picMkLst>
-        </pc:picChg>
         <pc:picChg chg="add del mod">
           <ac:chgData name="Jack Bond" userId="d0613b4d9d68792d" providerId="LiveId" clId="{DAEA3D54-AD02-4E1B-A73A-AB467D915B21}" dt="2025-10-09T03:13:16.776" v="416" actId="1076"/>
           <ac:picMkLst>
             <pc:docMk/>
             <pc:sldMk cId="3346064594" sldId="274"/>
             <ac:picMk id="1028" creationId="{8A7B853F-0284-EFBC-22EB-AB05DC715AE5}"/>
+          </ac:picMkLst>
+        </pc:picChg>
+      </pc:sldChg>
+      <pc:sldChg chg="addSp modSp new mod">
+        <pc:chgData name="Jack Bond" userId="d0613b4d9d68792d" providerId="LiveId" clId="{DAEA3D54-AD02-4E1B-A73A-AB467D915B21}" dt="2025-10-13T05:11:25.513" v="434" actId="1367"/>
+        <pc:sldMkLst>
+          <pc:docMk/>
+          <pc:sldMk cId="2238579761" sldId="275"/>
+        </pc:sldMkLst>
+        <pc:picChg chg="add mod">
+          <ac:chgData name="Jack Bond" userId="d0613b4d9d68792d" providerId="LiveId" clId="{DAEA3D54-AD02-4E1B-A73A-AB467D915B21}" dt="2025-10-13T05:11:25.513" v="434" actId="1367"/>
+          <ac:picMkLst>
+            <pc:docMk/>
+            <pc:sldMk cId="2238579761" sldId="275"/>
+            <ac:picMk id="3" creationId="{A9016CF3-304A-FF2B-4A3E-EF2166D566BB}"/>
           </ac:picMkLst>
         </pc:picChg>
       </pc:sldChg>
@@ -3795,6 +3683,85 @@
 </p:sld>
 </file>
 
+<file path=ppt/slides/slide2.xml><?xml version="1.0" encoding="utf-8"?>
+<p:sld xmlns:a="http://schemas.openxmlformats.org/drawingml/2006/main" xmlns:r="http://schemas.openxmlformats.org/officeDocument/2006/relationships" xmlns:p="http://schemas.openxmlformats.org/presentationml/2006/main">
+  <p:cSld>
+    <p:spTree>
+      <p:nvGrpSpPr>
+        <p:cNvPr id="1" name=""/>
+        <p:cNvGrpSpPr/>
+        <p:nvPr/>
+      </p:nvGrpSpPr>
+      <p:grpSpPr>
+        <a:xfrm>
+          <a:off x="0" y="0"/>
+          <a:ext cx="0" cy="0"/>
+          <a:chOff x="0" y="0"/>
+          <a:chExt cx="0" cy="0"/>
+        </a:xfrm>
+      </p:grpSpPr>
+      <p:pic>
+        <p:nvPicPr>
+          <p:cNvPr id="3" name="Picture 2" descr="A page of a book&#10;&#10;AI-generated content may be incorrect.">
+            <a:extLst>
+              <a:ext uri="{FF2B5EF4-FFF2-40B4-BE49-F238E27FC236}">
+                <a16:creationId xmlns:a16="http://schemas.microsoft.com/office/drawing/2014/main" id="{A9016CF3-304A-FF2B-4A3E-EF2166D566BB}"/>
+              </a:ext>
+            </a:extLst>
+          </p:cNvPr>
+          <p:cNvPicPr>
+            <a:picLocks noChangeAspect="1"/>
+          </p:cNvPicPr>
+          <p:nvPr/>
+        </p:nvPicPr>
+        <p:blipFill>
+          <a:blip r:embed="rId2">
+            <a:biLevel thresh="75000"/>
+            <a:extLst>
+              <a:ext uri="{BEBA8EAE-BF5A-486C-A8C5-ECC9F3942E4B}">
+                <a14:imgProps xmlns:a14="http://schemas.microsoft.com/office/drawing/2010/main">
+                  <a14:imgLayer r:embed="rId3">
+                    <a14:imgEffect>
+                      <a14:sharpenSoften amount="50000"/>
+                    </a14:imgEffect>
+                    <a14:imgEffect>
+                      <a14:brightnessContrast bright="40000" contrast="40000"/>
+                    </a14:imgEffect>
+                  </a14:imgLayer>
+                </a14:imgProps>
+              </a:ext>
+              <a:ext uri="{28A0092B-C50C-407E-A947-70E740481C1C}">
+                <a14:useLocalDpi xmlns:a14="http://schemas.microsoft.com/office/drawing/2010/main" val="0"/>
+              </a:ext>
+            </a:extLst>
+          </a:blip>
+          <a:stretch>
+            <a:fillRect/>
+          </a:stretch>
+        </p:blipFill>
+        <p:spPr>
+          <a:xfrm>
+            <a:off x="76200" y="1771650"/>
+            <a:ext cx="7620000" cy="6515100"/>
+          </a:xfrm>
+          <a:prstGeom prst="rect">
+            <a:avLst/>
+          </a:prstGeom>
+        </p:spPr>
+      </p:pic>
+    </p:spTree>
+    <p:extLst>
+      <p:ext uri="{BB962C8B-B14F-4D97-AF65-F5344CB8AC3E}">
+        <p14:creationId xmlns:p14="http://schemas.microsoft.com/office/powerpoint/2010/main" val="2238579761"/>
+      </p:ext>
+    </p:extLst>
+  </p:cSld>
+  <p:clrMapOvr>
+    <a:masterClrMapping/>
+  </p:clrMapOvr>
+</p:sld>
+</file>
+
 <file path=ppt/theme/theme1.xml><?xml version="1.0" encoding="utf-8"?>
 <a:theme xmlns:a="http://schemas.openxmlformats.org/drawingml/2006/main" name="Office Theme">
   <a:themeElements>

</xml_diff>

<commit_message>
Quartz sync: Oct 20, 2025, 10:20 AM
</commit_message>
<xml_diff>
--- a/content/Articles/session38tokens.pptx
+++ b/content/Articles/session38tokens.pptx
@@ -116,7 +116,7 @@
 <file path=ppt/revisionInfo.xml><?xml version="1.0" encoding="utf-8"?>
 <p1510:revInfo xmlns:a="http://schemas.openxmlformats.org/drawingml/2006/main" xmlns:r="http://schemas.openxmlformats.org/officeDocument/2006/relationships" xmlns:p1510="http://schemas.microsoft.com/office/powerpoint/2015/10/main">
   <p1510:revLst>
-    <p1510:client id="{C7780FBE-675A-4695-950B-AC815F932029}" v="252" dt="2025-10-13T05:11:25.515"/>
+    <p1510:client id="{C7780FBE-675A-4695-950B-AC815F932029}" v="326" dt="2025-10-14T20:16:47.290"/>
   </p1510:revLst>
 </p1510:revInfo>
 </file>
@@ -126,7 +126,7 @@
   <pc:docChgLst>
     <pc:chgData name="Jack Bond" userId="d0613b4d9d68792d" providerId="LiveId" clId="{DAEA3D54-AD02-4E1B-A73A-AB467D915B21}"/>
     <pc:docChg chg="undo custSel addSld delSld modSld">
-      <pc:chgData name="Jack Bond" userId="d0613b4d9d68792d" providerId="LiveId" clId="{DAEA3D54-AD02-4E1B-A73A-AB467D915B21}" dt="2025-10-13T05:11:25.513" v="434" actId="1367"/>
+      <pc:chgData name="Jack Bond" userId="d0613b4d9d68792d" providerId="LiveId" clId="{DAEA3D54-AD02-4E1B-A73A-AB467D915B21}" dt="2025-10-14T20:16:47.281" v="507" actId="1076"/>
       <pc:docMkLst>
         <pc:docMk/>
       </pc:docMkLst>
@@ -145,11 +145,19 @@
         </pc:sldMkLst>
       </pc:sldChg>
       <pc:sldChg chg="addSp delSp modSp new mod">
-        <pc:chgData name="Jack Bond" userId="d0613b4d9d68792d" providerId="LiveId" clId="{DAEA3D54-AD02-4E1B-A73A-AB467D915B21}" dt="2025-10-09T03:14:06.543" v="427" actId="1076"/>
+        <pc:chgData name="Jack Bond" userId="d0613b4d9d68792d" providerId="LiveId" clId="{DAEA3D54-AD02-4E1B-A73A-AB467D915B21}" dt="2025-10-14T20:16:47.281" v="507" actId="1076"/>
         <pc:sldMkLst>
           <pc:docMk/>
           <pc:sldMk cId="3346064594" sldId="274"/>
         </pc:sldMkLst>
+        <pc:spChg chg="add">
+          <ac:chgData name="Jack Bond" userId="d0613b4d9d68792d" providerId="LiveId" clId="{DAEA3D54-AD02-4E1B-A73A-AB467D915B21}" dt="2025-10-14T20:02:36.598" v="442"/>
+          <ac:spMkLst>
+            <pc:docMk/>
+            <pc:sldMk cId="3346064594" sldId="274"/>
+            <ac:spMk id="6" creationId="{9E014D8A-97B7-BA4E-971B-C143C70AB5B0}"/>
+          </ac:spMkLst>
+        </pc:spChg>
         <pc:grpChg chg="add mod">
           <ac:chgData name="Jack Bond" userId="d0613b4d9d68792d" providerId="LiveId" clId="{DAEA3D54-AD02-4E1B-A73A-AB467D915B21}" dt="2025-10-09T01:20:14.051" v="2"/>
           <ac:grpSpMkLst>
@@ -159,7 +167,7 @@
           </ac:grpSpMkLst>
         </pc:grpChg>
         <pc:grpChg chg="add mod">
-          <ac:chgData name="Jack Bond" userId="d0613b4d9d68792d" providerId="LiveId" clId="{DAEA3D54-AD02-4E1B-A73A-AB467D915B21}" dt="2025-10-09T03:14:06.543" v="427" actId="1076"/>
+          <ac:chgData name="Jack Bond" userId="d0613b4d9d68792d" providerId="LiveId" clId="{DAEA3D54-AD02-4E1B-A73A-AB467D915B21}" dt="2025-10-14T20:12:41.003" v="472" actId="1076"/>
           <ac:grpSpMkLst>
             <pc:docMk/>
             <pc:sldMk cId="3346064594" sldId="274"/>
@@ -167,7 +175,7 @@
           </ac:grpSpMkLst>
         </pc:grpChg>
         <pc:grpChg chg="add mod">
-          <ac:chgData name="Jack Bond" userId="d0613b4d9d68792d" providerId="LiveId" clId="{DAEA3D54-AD02-4E1B-A73A-AB467D915B21}" dt="2025-10-09T03:14:03.391" v="426" actId="1076"/>
+          <ac:chgData name="Jack Bond" userId="d0613b4d9d68792d" providerId="LiveId" clId="{DAEA3D54-AD02-4E1B-A73A-AB467D915B21}" dt="2025-10-14T20:12:41.003" v="472" actId="1076"/>
           <ac:grpSpMkLst>
             <pc:docMk/>
             <pc:sldMk cId="3346064594" sldId="274"/>
@@ -190,8 +198,8 @@
             <ac:picMk id="4" creationId="{1D154CDE-4FCC-8876-E2E7-F88EFE445222}"/>
           </ac:picMkLst>
         </pc:picChg>
-        <pc:picChg chg="add mod">
-          <ac:chgData name="Jack Bond" userId="d0613b4d9d68792d" providerId="LiveId" clId="{DAEA3D54-AD02-4E1B-A73A-AB467D915B21}" dt="2025-10-09T01:20:41.407" v="3"/>
+        <pc:picChg chg="add del mod">
+          <ac:chgData name="Jack Bond" userId="d0613b4d9d68792d" providerId="LiveId" clId="{DAEA3D54-AD02-4E1B-A73A-AB467D915B21}" dt="2025-10-14T19:57:53.854" v="435" actId="478"/>
           <ac:picMkLst>
             <pc:docMk/>
             <pc:sldMk cId="3346064594" sldId="274"/>
@@ -199,7 +207,15 @@
           </ac:picMkLst>
         </pc:picChg>
         <pc:picChg chg="add mod">
-          <ac:chgData name="Jack Bond" userId="d0613b4d9d68792d" providerId="LiveId" clId="{DAEA3D54-AD02-4E1B-A73A-AB467D915B21}" dt="2025-10-09T02:35:01.813" v="204" actId="164"/>
+          <ac:chgData name="Jack Bond" userId="d0613b4d9d68792d" providerId="LiveId" clId="{DAEA3D54-AD02-4E1B-A73A-AB467D915B21}" dt="2025-10-14T20:12:41.003" v="472" actId="1076"/>
+          <ac:picMkLst>
+            <pc:docMk/>
+            <pc:sldMk cId="3346064594" sldId="274"/>
+            <ac:picMk id="7" creationId="{A9BCDA1F-B3E3-C807-1A98-AB965A5ADB39}"/>
+          </ac:picMkLst>
+        </pc:picChg>
+        <pc:picChg chg="add mod">
+          <ac:chgData name="Jack Bond" userId="d0613b4d9d68792d" providerId="LiveId" clId="{DAEA3D54-AD02-4E1B-A73A-AB467D915B21}" dt="2025-10-14T20:12:41.003" v="472" actId="1076"/>
           <ac:picMkLst>
             <pc:docMk/>
             <pc:sldMk cId="3346064594" sldId="274"/>
@@ -207,7 +223,7 @@
           </ac:picMkLst>
         </pc:picChg>
         <pc:picChg chg="add mod">
-          <ac:chgData name="Jack Bond" userId="d0613b4d9d68792d" providerId="LiveId" clId="{DAEA3D54-AD02-4E1B-A73A-AB467D915B21}" dt="2025-10-09T02:35:01.813" v="204" actId="164"/>
+          <ac:chgData name="Jack Bond" userId="d0613b4d9d68792d" providerId="LiveId" clId="{DAEA3D54-AD02-4E1B-A73A-AB467D915B21}" dt="2025-10-14T20:12:41.003" v="472" actId="1076"/>
           <ac:picMkLst>
             <pc:docMk/>
             <pc:sldMk cId="3346064594" sldId="274"/>
@@ -215,15 +231,7 @@
           </ac:picMkLst>
         </pc:picChg>
         <pc:picChg chg="add mod">
-          <ac:chgData name="Jack Bond" userId="d0613b4d9d68792d" providerId="LiveId" clId="{DAEA3D54-AD02-4E1B-A73A-AB467D915B21}" dt="2025-10-09T03:13:16.776" v="416" actId="1076"/>
-          <ac:picMkLst>
-            <pc:docMk/>
-            <pc:sldMk cId="3346064594" sldId="274"/>
-            <ac:picMk id="19" creationId="{1A00948C-F427-647D-B373-49B3BD958E81}"/>
-          </ac:picMkLst>
-        </pc:picChg>
-        <pc:picChg chg="add mod">
-          <ac:chgData name="Jack Bond" userId="d0613b4d9d68792d" providerId="LiveId" clId="{DAEA3D54-AD02-4E1B-A73A-AB467D915B21}" dt="2025-10-09T03:13:56.769" v="425" actId="164"/>
+          <ac:chgData name="Jack Bond" userId="d0613b4d9d68792d" providerId="LiveId" clId="{DAEA3D54-AD02-4E1B-A73A-AB467D915B21}" dt="2025-10-14T20:12:41.003" v="472" actId="1076"/>
           <ac:picMkLst>
             <pc:docMk/>
             <pc:sldMk cId="3346064594" sldId="274"/>
@@ -231,19 +239,35 @@
           </ac:picMkLst>
         </pc:picChg>
         <pc:picChg chg="add mod">
-          <ac:chgData name="Jack Bond" userId="d0613b4d9d68792d" providerId="LiveId" clId="{DAEA3D54-AD02-4E1B-A73A-AB467D915B21}" dt="2025-10-09T03:13:56.769" v="425" actId="164"/>
+          <ac:chgData name="Jack Bond" userId="d0613b4d9d68792d" providerId="LiveId" clId="{DAEA3D54-AD02-4E1B-A73A-AB467D915B21}" dt="2025-10-14T20:12:41.003" v="472" actId="1076"/>
           <ac:picMkLst>
             <pc:docMk/>
             <pc:sldMk cId="3346064594" sldId="274"/>
             <ac:picMk id="29" creationId="{B04AA422-9FDF-A456-37FA-A579BEF350A6}"/>
           </ac:picMkLst>
         </pc:picChg>
-        <pc:picChg chg="add del mod">
-          <ac:chgData name="Jack Bond" userId="d0613b4d9d68792d" providerId="LiveId" clId="{DAEA3D54-AD02-4E1B-A73A-AB467D915B21}" dt="2025-10-09T03:13:16.776" v="416" actId="1076"/>
+        <pc:picChg chg="add mod">
+          <ac:chgData name="Jack Bond" userId="d0613b4d9d68792d" providerId="LiveId" clId="{DAEA3D54-AD02-4E1B-A73A-AB467D915B21}" dt="2025-10-14T20:16:42.369" v="504" actId="1076"/>
           <ac:picMkLst>
             <pc:docMk/>
             <pc:sldMk cId="3346064594" sldId="274"/>
-            <ac:picMk id="1028" creationId="{8A7B853F-0284-EFBC-22EB-AB05DC715AE5}"/>
+            <ac:picMk id="1026" creationId="{E81AABFD-223E-7D5C-C105-B3085B57F18F}"/>
+          </ac:picMkLst>
+        </pc:picChg>
+        <pc:picChg chg="add mod">
+          <ac:chgData name="Jack Bond" userId="d0613b4d9d68792d" providerId="LiveId" clId="{DAEA3D54-AD02-4E1B-A73A-AB467D915B21}" dt="2025-10-14T20:12:41.003" v="472" actId="1076"/>
+          <ac:picMkLst>
+            <pc:docMk/>
+            <pc:sldMk cId="3346064594" sldId="274"/>
+            <ac:picMk id="1030" creationId="{F1CFD9B0-2051-1FF8-F576-C35665BDED89}"/>
+          </ac:picMkLst>
+        </pc:picChg>
+        <pc:picChg chg="add mod">
+          <ac:chgData name="Jack Bond" userId="d0613b4d9d68792d" providerId="LiveId" clId="{DAEA3D54-AD02-4E1B-A73A-AB467D915B21}" dt="2025-10-14T20:16:47.281" v="507" actId="1076"/>
+          <ac:picMkLst>
+            <pc:docMk/>
+            <pc:sldMk cId="3346064594" sldId="274"/>
+            <ac:picMk id="1032" creationId="{16CBFF90-611E-6A9F-AECC-E846F11A7BCA}"/>
           </ac:picMkLst>
         </pc:picChg>
       </pc:sldChg>
@@ -623,7 +647,7 @@
           <a:p>
             <a:fld id="{1C4BEB1E-4C7A-4CCA-99B1-324C18C730E6}" type="datetimeFigureOut">
               <a:rPr lang="en-US" smtClean="0"/>
-              <a:t>10/8/2025</a:t>
+              <a:t>10/14/2025</a:t>
             </a:fld>
             <a:endParaRPr lang="en-US"/>
           </a:p>
@@ -793,7 +817,7 @@
           <a:p>
             <a:fld id="{1C4BEB1E-4C7A-4CCA-99B1-324C18C730E6}" type="datetimeFigureOut">
               <a:rPr lang="en-US" smtClean="0"/>
-              <a:t>10/8/2025</a:t>
+              <a:t>10/14/2025</a:t>
             </a:fld>
             <a:endParaRPr lang="en-US"/>
           </a:p>
@@ -973,7 +997,7 @@
           <a:p>
             <a:fld id="{1C4BEB1E-4C7A-4CCA-99B1-324C18C730E6}" type="datetimeFigureOut">
               <a:rPr lang="en-US" smtClean="0"/>
-              <a:t>10/8/2025</a:t>
+              <a:t>10/14/2025</a:t>
             </a:fld>
             <a:endParaRPr lang="en-US"/>
           </a:p>
@@ -1143,7 +1167,7 @@
           <a:p>
             <a:fld id="{1C4BEB1E-4C7A-4CCA-99B1-324C18C730E6}" type="datetimeFigureOut">
               <a:rPr lang="en-US" smtClean="0"/>
-              <a:t>10/8/2025</a:t>
+              <a:t>10/14/2025</a:t>
             </a:fld>
             <a:endParaRPr lang="en-US"/>
           </a:p>
@@ -1387,7 +1411,7 @@
           <a:p>
             <a:fld id="{1C4BEB1E-4C7A-4CCA-99B1-324C18C730E6}" type="datetimeFigureOut">
               <a:rPr lang="en-US" smtClean="0"/>
-              <a:t>10/8/2025</a:t>
+              <a:t>10/14/2025</a:t>
             </a:fld>
             <a:endParaRPr lang="en-US"/>
           </a:p>
@@ -1619,7 +1643,7 @@
           <a:p>
             <a:fld id="{1C4BEB1E-4C7A-4CCA-99B1-324C18C730E6}" type="datetimeFigureOut">
               <a:rPr lang="en-US" smtClean="0"/>
-              <a:t>10/8/2025</a:t>
+              <a:t>10/14/2025</a:t>
             </a:fld>
             <a:endParaRPr lang="en-US"/>
           </a:p>
@@ -1986,7 +2010,7 @@
           <a:p>
             <a:fld id="{1C4BEB1E-4C7A-4CCA-99B1-324C18C730E6}" type="datetimeFigureOut">
               <a:rPr lang="en-US" smtClean="0"/>
-              <a:t>10/8/2025</a:t>
+              <a:t>10/14/2025</a:t>
             </a:fld>
             <a:endParaRPr lang="en-US"/>
           </a:p>
@@ -2104,7 +2128,7 @@
           <a:p>
             <a:fld id="{1C4BEB1E-4C7A-4CCA-99B1-324C18C730E6}" type="datetimeFigureOut">
               <a:rPr lang="en-US" smtClean="0"/>
-              <a:t>10/8/2025</a:t>
+              <a:t>10/14/2025</a:t>
             </a:fld>
             <a:endParaRPr lang="en-US"/>
           </a:p>
@@ -2199,7 +2223,7 @@
           <a:p>
             <a:fld id="{1C4BEB1E-4C7A-4CCA-99B1-324C18C730E6}" type="datetimeFigureOut">
               <a:rPr lang="en-US" smtClean="0"/>
-              <a:t>10/8/2025</a:t>
+              <a:t>10/14/2025</a:t>
             </a:fld>
             <a:endParaRPr lang="en-US"/>
           </a:p>
@@ -2476,7 +2500,7 @@
           <a:p>
             <a:fld id="{1C4BEB1E-4C7A-4CCA-99B1-324C18C730E6}" type="datetimeFigureOut">
               <a:rPr lang="en-US" smtClean="0"/>
-              <a:t>10/8/2025</a:t>
+              <a:t>10/14/2025</a:t>
             </a:fld>
             <a:endParaRPr lang="en-US"/>
           </a:p>
@@ -2733,7 +2757,7 @@
           <a:p>
             <a:fld id="{1C4BEB1E-4C7A-4CCA-99B1-324C18C730E6}" type="datetimeFigureOut">
               <a:rPr lang="en-US" smtClean="0"/>
-              <a:t>10/8/2025</a:t>
+              <a:t>10/14/2025</a:t>
             </a:fld>
             <a:endParaRPr lang="en-US"/>
           </a:p>
@@ -2946,7 +2970,7 @@
           <a:p>
             <a:fld id="{1C4BEB1E-4C7A-4CCA-99B1-324C18C730E6}" type="datetimeFigureOut">
               <a:rPr lang="en-US" smtClean="0"/>
-              <a:t>10/8/2025</a:t>
+              <a:t>10/14/2025</a:t>
             </a:fld>
             <a:endParaRPr lang="en-US"/>
           </a:p>
@@ -3472,42 +3496,6 @@
           </p:spPr>
         </p:pic>
       </p:grpSp>
-      <p:pic>
-        <p:nvPicPr>
-          <p:cNvPr id="5" name="Picture 4" descr="A screenshot of a card&#10;&#10;AI-generated content may be incorrect.">
-            <a:extLst>
-              <a:ext uri="{FF2B5EF4-FFF2-40B4-BE49-F238E27FC236}">
-                <a16:creationId xmlns:a16="http://schemas.microsoft.com/office/drawing/2014/main" id="{26BE9FC6-9628-A31C-CB60-62A6930FD294}"/>
-              </a:ext>
-            </a:extLst>
-          </p:cNvPr>
-          <p:cNvPicPr>
-            <a:picLocks noChangeAspect="1"/>
-          </p:cNvPicPr>
-          <p:nvPr/>
-        </p:nvPicPr>
-        <p:blipFill>
-          <a:blip r:embed="rId3">
-            <a:extLst>
-              <a:ext uri="{28A0092B-C50C-407E-A947-70E740481C1C}">
-                <a14:useLocalDpi xmlns:a14="http://schemas.microsoft.com/office/drawing/2010/main" val="0"/>
-              </a:ext>
-            </a:extLst>
-          </a:blip>
-          <a:stretch>
-            <a:fillRect/>
-          </a:stretch>
-        </p:blipFill>
-        <p:spPr>
-          <a:xfrm>
-            <a:off x="211999" y="5029200"/>
-            <a:ext cx="3592286" cy="5029200"/>
-          </a:xfrm>
-          <a:prstGeom prst="rect">
-            <a:avLst/>
-          </a:prstGeom>
-        </p:spPr>
-      </p:pic>
       <p:grpSp>
         <p:nvGrpSpPr>
           <p:cNvPr id="17" name="Group 16">
@@ -3522,7 +3510,7 @@
         </p:nvGrpSpPr>
         <p:grpSpPr>
           <a:xfrm rot="5400000">
-            <a:off x="961803" y="3750032"/>
+            <a:off x="961803" y="4362206"/>
             <a:ext cx="1669230" cy="380291"/>
             <a:chOff x="2107824" y="3619374"/>
             <a:chExt cx="1669230" cy="380291"/>
@@ -3543,7 +3531,7 @@
             <p:nvPr/>
           </p:nvPicPr>
           <p:blipFill>
-            <a:blip r:embed="rId4"/>
+            <a:blip r:embed="rId3"/>
             <a:stretch>
               <a:fillRect/>
             </a:stretch>
@@ -3573,7 +3561,7 @@
             <p:nvPr/>
           </p:nvPicPr>
           <p:blipFill>
-            <a:blip r:embed="rId4"/>
+            <a:blip r:embed="rId3"/>
             <a:stretch>
               <a:fillRect/>
             </a:stretch>
@@ -3603,7 +3591,7 @@
         </p:nvGrpSpPr>
         <p:grpSpPr>
           <a:xfrm>
-            <a:off x="2429764" y="2846905"/>
+            <a:off x="2429764" y="3459079"/>
             <a:ext cx="2912871" cy="2377646"/>
             <a:chOff x="2383057" y="2773023"/>
             <a:chExt cx="2912871" cy="2377646"/>
@@ -3624,7 +3612,7 @@
             <p:nvPr/>
           </p:nvPicPr>
           <p:blipFill>
-            <a:blip r:embed="rId5"/>
+            <a:blip r:embed="rId4"/>
             <a:stretch>
               <a:fillRect/>
             </a:stretch>
@@ -3654,7 +3642,7 @@
             <p:nvPr/>
           </p:nvPicPr>
           <p:blipFill>
-            <a:blip r:embed="rId5"/>
+            <a:blip r:embed="rId4"/>
             <a:stretch>
               <a:fillRect/>
             </a:stretch>
@@ -3670,6 +3658,203 @@
           </p:spPr>
         </p:pic>
       </p:grpSp>
+      <p:pic>
+        <p:nvPicPr>
+          <p:cNvPr id="1026" name="Picture 2" descr="Astrolabe Illustration Stock Illustrations – 591 Astrolabe Illustration  Stock Illustrations, Vectors &amp; Clipart - Dreamstime">
+            <a:extLst>
+              <a:ext uri="{FF2B5EF4-FFF2-40B4-BE49-F238E27FC236}">
+                <a16:creationId xmlns:a16="http://schemas.microsoft.com/office/drawing/2014/main" id="{E81AABFD-223E-7D5C-C105-B3085B57F18F}"/>
+              </a:ext>
+            </a:extLst>
+          </p:cNvPr>
+          <p:cNvPicPr>
+            <a:picLocks noChangeAspect="1" noChangeArrowheads="1"/>
+          </p:cNvPicPr>
+          <p:nvPr/>
+        </p:nvPicPr>
+        <p:blipFill>
+          <a:blip r:embed="rId5">
+            <a:extLst>
+              <a:ext uri="{28A0092B-C50C-407E-A947-70E740481C1C}">
+                <a14:useLocalDpi xmlns:a14="http://schemas.microsoft.com/office/drawing/2010/main" val="0"/>
+              </a:ext>
+            </a:extLst>
+          </a:blip>
+          <a:srcRect/>
+          <a:stretch>
+            <a:fillRect/>
+          </a:stretch>
+        </p:blipFill>
+        <p:spPr bwMode="auto">
+          <a:xfrm>
+            <a:off x="260047" y="5862125"/>
+            <a:ext cx="4259498" cy="3652519"/>
+          </a:xfrm>
+          <a:prstGeom prst="rect">
+            <a:avLst/>
+          </a:prstGeom>
+          <a:noFill/>
+          <a:extLst>
+            <a:ext uri="{909E8E84-426E-40DD-AFC4-6F175D3DCCD1}">
+              <a14:hiddenFill xmlns:a14="http://schemas.microsoft.com/office/drawing/2010/main">
+                <a:solidFill>
+                  <a:srgbClr val="FFFFFF"/>
+                </a:solidFill>
+              </a14:hiddenFill>
+            </a:ext>
+          </a:extLst>
+        </p:spPr>
+      </p:pic>
+      <p:pic>
+        <p:nvPicPr>
+          <p:cNvPr id="1030" name="Picture 6" descr="Leedara&quot; and &quot;Leedara, the Ghost&quot;. Made for Dragonlance: Shadow of the  Dragon Queen. Art Director: Kate Irwin #dragonlance #dungeonsanddragons #DnD  #dndart #illustration #digitalpainting #digitalart #fantasy #fantasyart # ghost #characterdesign">
+            <a:extLst>
+              <a:ext uri="{FF2B5EF4-FFF2-40B4-BE49-F238E27FC236}">
+                <a16:creationId xmlns:a16="http://schemas.microsoft.com/office/drawing/2014/main" id="{F1CFD9B0-2051-1FF8-F576-C35665BDED89}"/>
+              </a:ext>
+            </a:extLst>
+          </p:cNvPr>
+          <p:cNvPicPr>
+            <a:picLocks noChangeAspect="1" noChangeArrowheads="1"/>
+          </p:cNvPicPr>
+          <p:nvPr/>
+        </p:nvPicPr>
+        <p:blipFill rotWithShape="1">
+          <a:blip r:embed="rId6">
+            <a:alphaModFix amt="50000"/>
+            <a:extLst>
+              <a:ext uri="{28A0092B-C50C-407E-A947-70E740481C1C}">
+                <a14:useLocalDpi xmlns:a14="http://schemas.microsoft.com/office/drawing/2010/main" val="0"/>
+              </a:ext>
+            </a:extLst>
+          </a:blip>
+          <a:srcRect l="37132" r="37388" b="74161"/>
+          <a:stretch>
+            <a:fillRect/>
+          </a:stretch>
+        </p:blipFill>
+        <p:spPr bwMode="auto">
+          <a:xfrm>
+            <a:off x="5772305" y="3931922"/>
+            <a:ext cx="669925" cy="679293"/>
+          </a:xfrm>
+          <a:prstGeom prst="rect">
+            <a:avLst/>
+          </a:prstGeom>
+          <a:noFill/>
+          <a:extLst>
+            <a:ext uri="{909E8E84-426E-40DD-AFC4-6F175D3DCCD1}">
+              <a14:hiddenFill xmlns:a14="http://schemas.microsoft.com/office/drawing/2010/main">
+                <a:solidFill>
+                  <a:srgbClr val="FFFFFF"/>
+                </a:solidFill>
+              </a14:hiddenFill>
+            </a:ext>
+          </a:extLst>
+        </p:spPr>
+      </p:pic>
+      <p:pic>
+        <p:nvPicPr>
+          <p:cNvPr id="7" name="Picture 6" descr="Leedara&quot; and &quot;Leedara, the Ghost&quot;. Made for Dragonlance: Shadow of the  Dragon Queen. Art Director: Kate Irwin #dragonlance #dungeonsanddragons #DnD  #dndart #illustration #digitalpainting #digitalart #fantasy #fantasyart # ghost #characterdesign">
+            <a:extLst>
+              <a:ext uri="{FF2B5EF4-FFF2-40B4-BE49-F238E27FC236}">
+                <a16:creationId xmlns:a16="http://schemas.microsoft.com/office/drawing/2014/main" id="{A9BCDA1F-B3E3-C807-1A98-AB965A5ADB39}"/>
+              </a:ext>
+            </a:extLst>
+          </p:cNvPr>
+          <p:cNvPicPr>
+            <a:picLocks noChangeAspect="1" noChangeArrowheads="1"/>
+          </p:cNvPicPr>
+          <p:nvPr/>
+        </p:nvPicPr>
+        <p:blipFill rotWithShape="1">
+          <a:blip r:embed="rId6">
+            <a:alphaModFix amt="50000"/>
+            <a:extLst>
+              <a:ext uri="{28A0092B-C50C-407E-A947-70E740481C1C}">
+                <a14:useLocalDpi xmlns:a14="http://schemas.microsoft.com/office/drawing/2010/main" val="0"/>
+              </a:ext>
+            </a:extLst>
+          </a:blip>
+          <a:srcRect l="37132" r="37388" b="74161"/>
+          <a:stretch>
+            <a:fillRect/>
+          </a:stretch>
+        </p:blipFill>
+        <p:spPr bwMode="auto">
+          <a:xfrm flipV="1">
+            <a:off x="5772306" y="4647902"/>
+            <a:ext cx="669925" cy="679293"/>
+          </a:xfrm>
+          <a:prstGeom prst="rect">
+            <a:avLst/>
+          </a:prstGeom>
+          <a:noFill/>
+          <a:extLst>
+            <a:ext uri="{909E8E84-426E-40DD-AFC4-6F175D3DCCD1}">
+              <a14:hiddenFill xmlns:a14="http://schemas.microsoft.com/office/drawing/2010/main">
+                <a:solidFill>
+                  <a:srgbClr val="FFFFFF"/>
+                </a:solidFill>
+              </a14:hiddenFill>
+            </a:ext>
+          </a:extLst>
+        </p:spPr>
+      </p:pic>
+      <p:pic>
+        <p:nvPicPr>
+          <p:cNvPr id="1032" name="Picture 8" descr="Rick and Morty's Most Gruesome Deaths | Den of Geek">
+            <a:extLst>
+              <a:ext uri="{FF2B5EF4-FFF2-40B4-BE49-F238E27FC236}">
+                <a16:creationId xmlns:a16="http://schemas.microsoft.com/office/drawing/2014/main" id="{16CBFF90-611E-6A9F-AECC-E846F11A7BCA}"/>
+              </a:ext>
+            </a:extLst>
+          </p:cNvPr>
+          <p:cNvPicPr>
+            <a:picLocks noChangeAspect="1" noChangeArrowheads="1"/>
+          </p:cNvPicPr>
+          <p:nvPr/>
+        </p:nvPicPr>
+        <p:blipFill rotWithShape="1">
+          <a:blip r:embed="rId7">
+            <a:duotone>
+              <a:prstClr val="black"/>
+              <a:srgbClr val="990000">
+                <a:tint val="45000"/>
+                <a:satMod val="400000"/>
+              </a:srgbClr>
+            </a:duotone>
+            <a:extLst>
+              <a:ext uri="{28A0092B-C50C-407E-A947-70E740481C1C}">
+                <a14:useLocalDpi xmlns:a14="http://schemas.microsoft.com/office/drawing/2010/main" val="0"/>
+              </a:ext>
+            </a:extLst>
+          </a:blip>
+          <a:srcRect l="17114" t="48336" r="70098" b="9041"/>
+          <a:stretch>
+            <a:fillRect/>
+          </a:stretch>
+        </p:blipFill>
+        <p:spPr bwMode="auto">
+          <a:xfrm>
+            <a:off x="5351854" y="6615280"/>
+            <a:ext cx="1144765" cy="2146207"/>
+          </a:xfrm>
+          <a:prstGeom prst="rect">
+            <a:avLst/>
+          </a:prstGeom>
+          <a:noFill/>
+          <a:extLst>
+            <a:ext uri="{909E8E84-426E-40DD-AFC4-6F175D3DCCD1}">
+              <a14:hiddenFill xmlns:a14="http://schemas.microsoft.com/office/drawing/2010/main">
+                <a:solidFill>
+                  <a:srgbClr val="FFFFFF"/>
+                </a:solidFill>
+              </a14:hiddenFill>
+            </a:ext>
+          </a:extLst>
+        </p:spPr>
+      </p:pic>
     </p:spTree>
     <p:extLst>
       <p:ext uri="{BB962C8B-B14F-4D97-AF65-F5344CB8AC3E}">

</xml_diff>